<commit_message>
feat(pitch): optimize 5-minute investor presentation, streamline team attribution, and update pptx
</commit_message>
<xml_diff>
--- a/Verxl_Protocol_Pitch_Presentation.pptx
+++ b/Verxl_Protocol_Pitch_Presentation.pptx
@@ -530,12 +530,12 @@
           <a:lstStyle/>
           <a:p>
             <a:r>
-              <a:t>SPEAKER SCRIPT (0:00 - 0:35)</a:t>
-            </a:r>
-          </a:p>
-          <a:p>
-            <a:r>
-              <a:t>Good morning. I'm Simon Havlík from the Faculty of International Relations at VŠE. Today, I'm presenting Verxl Protocol: a capital-light, decentralized clearing switch for global AI inference. Every day, millions of dollars are spent on AI inference through AWS, Azure, and OpenAI. These centralized giants charge 80 to 90% gross margins. Verxl replaces these predatory walled gardens with a stateless, non-custodial clearing protocol that charges only a 50 basis point clearing fee.</a:t>
+              <a:t>SPEAKER SCRIPT (0:00 - 0:25 · 25s)</a:t>
+            </a:r>
+          </a:p>
+          <a:p>
+            <a:r>
+              <a:t>Good morning. I'm Šimon Havlík from Prague University of Economics and Business. Today, I'm presenting Verxl Protocol: a capital-light, decentralized clearing switch for global AI inference. Hyperscalers like AWS and OpenAI extract 80 to 90% markups on commodity models while independent datacenters sit with idle GPUs. Verxl replaces this broken paradigm with a stateless, 50 basis point clearing switch settling natively on Arbitrum L2.</a:t>
             </a:r>
           </a:p>
         </p:txBody>
@@ -605,12 +605,12 @@
           <a:lstStyle/>
           <a:p>
             <a:r>
-              <a:t>SPEAKER SCRIPT (4:05 - 4:15)</a:t>
-            </a:r>
-          </a:p>
-          <a:p>
-            <a:r>
-              <a:t>How do we measure success, and how is the protocol protected from legal and market risks?</a:t>
+              <a:t>SPEAKER SCRIPT (3:30 - 3:40 · 10s)</a:t>
+            </a:r>
+          </a:p>
+          <a:p>
+            <a:r>
+              <a:t>How do we measure success, and how is the protocol protected from regulatory and financial risks?</a:t>
             </a:r>
           </a:p>
         </p:txBody>
@@ -680,12 +680,12 @@
           <a:lstStyle/>
           <a:p>
             <a:r>
-              <a:t>SPEAKER SCRIPT (4:05 - 4:35)</a:t>
-            </a:r>
-          </a:p>
-          <a:p>
-            <a:r>
-              <a:t>We evaluate success through four rigorous mathematical metrics: Gross volume, routing latency under 5 milliseconds, 99.99% uptime enforced by automated slashing, and treasury accumulation. Equally vital is legal defensibility under European law. Under the EU MiCA framework, Verxl is strictly non-custodial. We do not intermediate fiat, hold custody of deposits, or execute discretionary trades. Furthermore, because our edge router streams data without storing prompts on disk, we have complete GDPR and EU AI Act compliance. This creates an unassailable institutional moat.</a:t>
+              <a:t>SPEAKER SCRIPT (3:40 - 4:15 · 35s)</a:t>
+            </a:r>
+          </a:p>
+          <a:p>
+            <a:r>
+              <a:t>We evaluate success through four quantitative metrics: gross volume, sub-5 millisecond routing latency, 99.99% canary uptime, and treasury reserves. Equally vital is our institutional legal moat: under EU MiCA, Verxl is strictly non-custodial and exempt from CASP licensing. Furthermore, because our edge router streams data through RAM without storing prompts on disk, we have total GDPR and EU AI Act compliance.</a:t>
             </a:r>
           </a:p>
         </p:txBody>
@@ -755,12 +755,12 @@
           <a:lstStyle/>
           <a:p>
             <a:r>
-              <a:t>SPEAKER SCRIPT (4:35 - 4:45)</a:t>
-            </a:r>
-          </a:p>
-          <a:p>
-            <a:r>
-              <a:t>Finally, our technical and operational roadmap spanning 2026 through 2028.</a:t>
+              <a:t>SPEAKER SCRIPT (4:15 - 4:25 · 10s)</a:t>
+            </a:r>
+          </a:p>
+          <a:p>
+            <a:r>
+              <a:t>Finally, let's review our strategic roadmap spanning 2026 through 2028.</a:t>
             </a:r>
           </a:p>
         </p:txBody>
@@ -830,12 +830,12 @@
           <a:lstStyle/>
           <a:p>
             <a:r>
-              <a:t>SPEAKER SCRIPT (4:45 - 5:05)</a:t>
-            </a:r>
-          </a:p>
-          <a:p>
-            <a:r>
-              <a:t>To conclude, our roadmap spans four clear horizons. Horizon 1 is not a future promise — it is operational right now on mainnet at verxl.com. Horizon 2 introduces decentralized provider staking and automated canary slashing. Horizon 3 brings zero-knowledge cryptographic proofs of inference. And Horizon 4 unlocks the true machine-to-machine economy where autonomous AI agents pay each other directly via HTTP 402.</a:t>
+              <a:t>SPEAKER SCRIPT (4:25 - 4:55 · 30s)</a:t>
+            </a:r>
+          </a:p>
+          <a:p>
+            <a:r>
+              <a:t>Our roadmap spans four clear horizons. Horizon 1 is not a future promise — it is operational right now on mainnet at verxl.com. Horizon 2 brings decentralized provider staking and automated canary slashing. Horizon 3 introduces zero-knowledge cryptographic proofs of inference. And Horizon 4 unlocks the true machine-to-machine economy where autonomous AI agents pay each other directly via HTTP 402.</a:t>
             </a:r>
           </a:p>
         </p:txBody>
@@ -905,12 +905,12 @@
           <a:lstStyle/>
           <a:p>
             <a:r>
-              <a:t>SPEAKER SCRIPT (5:05 - 5:20)</a:t>
-            </a:r>
-          </a:p>
-          <a:p>
-            <a:r>
-              <a:t>Thank you for your time. The platform is live at verxl.com, our smart contracts are on-chain, and our documentation is open. I welcome any questions or feedback from the committee.</a:t>
+              <a:t>SPEAKER SCRIPT (4:55 - 5:00 · 5s)</a:t>
+            </a:r>
+          </a:p>
+          <a:p>
+            <a:r>
+              <a:t>Thank you for your time. Verxl is live today at verxl.com, and I look forward to your questions.</a:t>
             </a:r>
           </a:p>
         </p:txBody>
@@ -980,12 +980,12 @@
           <a:lstStyle/>
           <a:p>
             <a:r>
-              <a:t>SPEAKER SCRIPT (0:35 - 0:45)</a:t>
-            </a:r>
-          </a:p>
-          <a:p>
-            <a:r>
-              <a:t>Let's look at the core problem in the current artificial intelligence compute market.</a:t>
+              <a:t>SPEAKER SCRIPT (0:25 - 0:35 · 10s)</a:t>
+            </a:r>
+          </a:p>
+          <a:p>
+            <a:r>
+              <a:t>Let's begin with the core problem: the massive economic drag holding back artificial intelligence compute liquidity.</a:t>
             </a:r>
           </a:p>
         </p:txBody>
@@ -1055,12 +1055,12 @@
           <a:lstStyle/>
           <a:p>
             <a:r>
-              <a:t>SPEAKER SCRIPT (0:45 - 1:30)</a:t>
-            </a:r>
-          </a:p>
-          <a:p>
-            <a:r>
-              <a:t>Look at this breakdown: on the left, hyperscalers like AWS and OpenAI operate like feudal landlords. They markup open-source models like DeepSeek and Qwen by up to 90%, enforce mandatory identity surveillance, and freeze accounts arbitrarily. In the middle, independent datacenter operators across Europe and Asia have thousands of high-performance GPUs sitting idle because they lack retail distribution. On the right is our solution: Verxl Protocol. We built a stateless clearing switch at the edge. Developers plug in our OpenAI-compatible endpoint, their request is routed in 4 milliseconds to the best available compute node, and the protocol settles the transaction via Arbitrum Layer 2 for a microscopic 50 basis point clearing fee.</a:t>
+              <a:t>SPEAKER SCRIPT (0:35 - 1:10 · 35s)</a:t>
+            </a:r>
+          </a:p>
+          <a:p>
+            <a:r>
+              <a:t>On this slide, you see the market arbitrage. Hyperscalers charge 80 to 90% margins on open-weight models, while independent European datacenters sit with idle GPUs because they lack retail distribution. Verxl solves this with an edge switch: developers point their existing code to our OpenAI-compatible endpoint, requests route to the lowest-latency GPU in 4 milliseconds, and the protocol settles in USDC for just 50 basis points.</a:t>
             </a:r>
           </a:p>
         </p:txBody>
@@ -1130,12 +1130,12 @@
           <a:lstStyle/>
           <a:p>
             <a:r>
-              <a:t>SPEAKER SCRIPT (1:30 - 1:40)</a:t>
-            </a:r>
-          </a:p>
-          <a:p>
-            <a:r>
-              <a:t>Now, who is the customer, and why does this have massive product-market fit right now?</a:t>
+              <a:t>SPEAKER SCRIPT (1:10 - 1:20 · 10s)</a:t>
+            </a:r>
+          </a:p>
+          <a:p>
+            <a:r>
+              <a:t>Next, who is the customer, and why does this model achieve explosive product-market fit?</a:t>
             </a:r>
           </a:p>
         </p:txBody>
@@ -1205,12 +1205,12 @@
           <a:lstStyle/>
           <a:p>
             <a:r>
-              <a:t>SPEAKER SCRIPT (1:40 - 2:25)</a:t>
-            </a:r>
-          </a:p>
-          <a:p>
-            <a:r>
-              <a:t>As an economics and finance student, customer acquisition cost is everything. Our target audience consists of three interconnected crypto-native personas. First, tech-savvy developers building autonomous agents and quant bots. They don't want a corporate dashboard; they want a drop-in API. Second, privacy advocates and European fintech firms who cannot legally have their proprietary algorithms harvested by Silicon Valley giants. And third, crypto-native power users who rally around decentralized protocols. In traditional fintech, customer acquisition cost is $150 to $300. In Verxl, because users are incentivized by transparent on-chain clearing and DAO rewards, our customer acquisition cost is virtually zero. Every developer who switches from OpenAI immediately saves 90% and brings perpetual clearing volume.</a:t>
+              <a:t>SPEAKER SCRIPT (1:20 - 1:55 · 35s)</a:t>
+            </a:r>
+          </a:p>
+          <a:p>
+            <a:r>
+              <a:t>As a finance student, customer acquisition cost is paramount. Our audience consists of three crypto-native personas: tech-savvy bot developers, privacy-conscious fintech quants, and on-chain communities. Traditional SaaS companies burn hundreds of dollars on ad spend. In Verxl, our CAC is virtually zero because developers instantly save 90% on inference and participate directly in on-chain network rewards.</a:t>
             </a:r>
           </a:p>
         </p:txBody>
@@ -1280,12 +1280,12 @@
           <a:lstStyle/>
           <a:p>
             <a:r>
-              <a:t>SPEAKER SCRIPT (2:25 - 2:35)</a:t>
-            </a:r>
-          </a:p>
-          <a:p>
-            <a:r>
-              <a:t>Let me outline my direct role and technical execution in building this protocol.</a:t>
+              <a:t>SPEAKER SCRIPT (1:55 - 2:05 · 10s)</a:t>
+            </a:r>
+          </a:p>
+          <a:p>
+            <a:r>
+              <a:t>Let's examine the technical execution, proprietary architecture, and the team behind the protocol.</a:t>
             </a:r>
           </a:p>
         </p:txBody>
@@ -1355,12 +1355,12 @@
           <a:lstStyle/>
           <a:p>
             <a:r>
-              <a:t>SPEAKER SCRIPT (2:35 - 3:15)</a:t>
-            </a:r>
-          </a:p>
-          <a:p>
-            <a:r>
-              <a:t>My role is that of founder, full-stack quantitative architect, and systems engineer. I personally built all four layers of this protocol. First, on-chain: I deployed the Aragon OSx governance contracts, the $VRXL staking token, and the non-custodial escrow vaults. Second, the edge network: I built the stateless clearing router that executes in under 4 milliseconds and verifies node quality using our seed=42 canary engine. Third, the financial ledger: I designed the PostgreSQL transaction engine, PBKDF2 cryptographic password hashing, and RFC 6238 two-factor authentication. And fourth, physical infrastructure: I set up our bare-metal Vulkan cluster in Prague and automated key synchronization across our Oracle Cloud VMs. This is not a theoretical whitepaper; it is live, running software.</a:t>
+              <a:t>SPEAKER SCRIPT (2:05 - 2:40 · 35s)</a:t>
+            </a:r>
+          </a:p>
+          <a:p>
+            <a:r>
+              <a:t>Verxl is built on four proprietary pillars: First, on-chain Aragon OSx contracts manage non-custodial escrows and collateral. Second, our stateless edge router dispatches requests in 3.8 milliseconds with zero proxy latency. Third, our seed=42 canary oracle continuously audits provider output, slashing degraded nodes by 10%. And fourth, our Charizard PostgreSQL ledger manages real-time balance clearing with 2FA security. We note our core team: Šimon Havlík leading architecture and full-stack engineering, collaborating with academic project partners at VŠE.</a:t>
             </a:r>
           </a:p>
         </p:txBody>
@@ -1430,12 +1430,12 @@
           <a:lstStyle/>
           <a:p>
             <a:r>
-              <a:t>SPEAKER SCRIPT (3:15 - 3:25)</a:t>
-            </a:r>
-          </a:p>
-          <a:p>
-            <a:r>
-              <a:t>What is the ultimate financial and technological goal of Verxl Protocol?</a:t>
+              <a:t>SPEAKER SCRIPT (2:40 - 2:50 · 10s)</a:t>
+            </a:r>
+          </a:p>
+          <a:p>
+            <a:r>
+              <a:t>Now, let's explore our ultimate financial goal: building the decentralized clearinghouse for global AI.</a:t>
             </a:r>
           </a:p>
         </p:txBody>
@@ -1505,12 +1505,12 @@
           <a:lstStyle/>
           <a:p>
             <a:r>
-              <a:t>SPEAKER SCRIPT (3:25 - 4:05)</a:t>
-            </a:r>
-          </a:p>
-          <a:p>
-            <a:r>
-              <a:t>From an economic standpoint, look at our unit economics on slide 9. We have zero hardware capital expenditure. Zero depreciation. Zero electricity bills. Visa does not own banks; NASDAQ does not own stocks. They are clearinghouses. Verxl is the clearinghouse for artificial intelligence. On every dollar of compute cleared across our network, we collect 50 basis points. At 50 billion tokens a month, that is $3 million in monthly gross volume and $180,000 in annualized net protocol cash flow. At 1 trillion tokens — which top AI apps already process — the 50 bps switch yields $3.6 million annually in pure protocol revenue, flowing directly into the Aragon OSx DAO treasury to reward token stakers.</a:t>
+              <a:t>SPEAKER SCRIPT (2:50 - 3:30 · 40s)</a:t>
+            </a:r>
+          </a:p>
+          <a:p>
+            <a:r>
+              <a:t>From a finance perspective, our economics are extraordinarily compelling. We take zero hardware CapEx and zero depreciation risk. Just like Visa collects a toll on payments, Verxl collects 50 basis points on compute. At 50 billion tokens a month, that is $3 million in monthly gross volume and $180,000 in annualized protocol cash flow. At 1 trillion tokens, the 50 bps switch yields $3.6 million in annual net cash flow, distributed directly to DAO stakers.</a:t>
             </a:r>
           </a:p>
         </p:txBody>
@@ -4854,18 +4854,18 @@
           <a:p>
             <a:br/>
             <a:pPr>
-              <a:defRPr sz="1300">
+              <a:defRPr sz="1250">
                 <a:solidFill>
                   <a:srgbClr val="94A3B8"/>
                 </a:solidFill>
               </a:defRPr>
             </a:pPr>
             <a:r>
-              <a:t>Simon Havlík · VŠE Faculty of International Relations</a:t>
+              <a:t>Šimon Havlík · Prague University of Economics and Business (VŠE Praha)</a:t>
             </a:r>
             <a:br/>
             <a:r>
-              <a:t>Course: 2SE307 Bitcoin &amp; Blockchain · Instructor: M. Bok</a:t>
+              <a:t>Academic University Project Collaboration · 2026</a:t>
             </a:r>
           </a:p>
         </p:txBody>
@@ -5111,7 +5111,7 @@
         <p:spPr>
           <a:xfrm>
             <a:off x="548640" y="365760"/>
-            <a:ext cx="11064240" cy="731520"/>
+            <a:ext cx="11064240" cy="777240"/>
           </a:xfrm>
           <a:prstGeom prst="rect">
             <a:avLst/>
@@ -5125,7 +5125,7 @@
           <a:lstStyle/>
           <a:p>
             <a:pPr>
-              <a:defRPr sz="2400" b="1">
+              <a:defRPr sz="2300" b="1">
                 <a:solidFill>
                   <a:srgbClr val="FFFFFF"/>
                 </a:solidFill>
@@ -5138,7 +5138,7 @@
           </a:p>
           <a:p>
             <a:pPr>
-              <a:defRPr sz="1300">
+              <a:defRPr sz="1200">
                 <a:solidFill>
                   <a:srgbClr val="38BDF8"/>
                 </a:solidFill>
@@ -5189,11 +5189,11 @@
           </a:fontRef>
         </p:style>
         <p:txBody>
-          <a:bodyPr rtlCol="0" anchor="ctr" wrap="square" lIns="228600" tIns="228600" rIns="228600" bIns="228600"/>
+          <a:bodyPr rtlCol="0" anchor="ctr" wrap="square" lIns="201168" tIns="201168" rIns="201168" bIns="201168"/>
           <a:lstStyle/>
           <a:p>
             <a:pPr algn="ctr">
-              <a:defRPr b="1" sz="1300">
+              <a:defRPr b="1" sz="1250">
                 <a:solidFill>
                   <a:srgbClr val="34D399"/>
                 </a:solidFill>
@@ -5206,7 +5206,7 @@
           <a:p>
             <a:br/>
             <a:pPr>
-              <a:defRPr b="1" sz="1050">
+              <a:defRPr b="1" sz="1000">
                 <a:solidFill>
                   <a:srgbClr val="FFFFFF"/>
                 </a:solidFill>
@@ -5218,7 +5218,7 @@
           </a:p>
           <a:p>
             <a:pPr>
-              <a:defRPr sz="900">
+              <a:defRPr sz="850">
                 <a:solidFill>
                   <a:srgbClr val="94A3B8"/>
                 </a:solidFill>
@@ -5231,7 +5231,7 @@
           <a:p>
             <a:br/>
             <a:pPr>
-              <a:defRPr b="1" sz="1050">
+              <a:defRPr b="1" sz="1000">
                 <a:solidFill>
                   <a:srgbClr val="FFFFFF"/>
                 </a:solidFill>
@@ -5243,20 +5243,20 @@
           </a:p>
           <a:p>
             <a:pPr>
-              <a:defRPr sz="900">
+              <a:defRPr sz="850">
                 <a:solidFill>
                   <a:srgbClr val="94A3B8"/>
                 </a:solidFill>
               </a:defRPr>
             </a:pPr>
             <a:r>
-              <a:t>Edge proxy overhead strictly capped below 5ms (measured 3.8ms on Cloudflare edge).</a:t>
+              <a:t>Edge proxy overhead strictly capped below 5ms (measured 3.8ms in production).</a:t>
             </a:r>
           </a:p>
           <a:p>
             <a:br/>
             <a:pPr>
-              <a:defRPr b="1" sz="1050">
+              <a:defRPr b="1" sz="1000">
                 <a:solidFill>
                   <a:srgbClr val="FFFFFF"/>
                 </a:solidFill>
@@ -5268,32 +5268,32 @@
           </a:p>
           <a:p>
             <a:pPr>
-              <a:defRPr sz="900">
+              <a:defRPr sz="850">
                 <a:solidFill>
                   <a:srgbClr val="94A3B8"/>
                 </a:solidFill>
               </a:defRPr>
             </a:pPr>
             <a:r>
-              <a:t>Zero tolerance for degraded nodes: automated seed=42 canary slashing enforces 99.99% model accuracy.</a:t>
+              <a:t>Zero tolerance for degraded nodes: automated seed=42 slashing enforces 99.99% model accuracy.</a:t>
             </a:r>
           </a:p>
           <a:p>
             <a:br/>
             <a:pPr>
-              <a:defRPr b="1" sz="1050">
+              <a:defRPr b="1" sz="1000">
                 <a:solidFill>
                   <a:srgbClr val="FFFFFF"/>
                 </a:solidFill>
               </a:defRPr>
             </a:pPr>
             <a:r>
-              <a:t>• DAO Treasury Growth &amp; Deflation</a:t>
-            </a:r>
-          </a:p>
-          <a:p>
-            <a:pPr>
-              <a:defRPr sz="900">
+              <a:t>• DAO Treasury Growth &amp; Reserves</a:t>
+            </a:r>
+          </a:p>
+          <a:p>
+            <a:pPr>
+              <a:defRPr sz="850">
                 <a:solidFill>
                   <a:srgbClr val="94A3B8"/>
                 </a:solidFill>
@@ -5343,11 +5343,11 @@
           </a:fontRef>
         </p:style>
         <p:txBody>
-          <a:bodyPr rtlCol="0" anchor="ctr" wrap="square" lIns="228600" tIns="228600" rIns="228600" bIns="228600"/>
+          <a:bodyPr rtlCol="0" anchor="ctr" wrap="square" lIns="201168" tIns="201168" rIns="201168" bIns="201168"/>
           <a:lstStyle/>
           <a:p>
             <a:pPr algn="ctr">
-              <a:defRPr b="1" sz="1300">
+              <a:defRPr b="1" sz="1250">
                 <a:solidFill>
                   <a:srgbClr val="38BDF8"/>
                 </a:solidFill>
@@ -5360,7 +5360,7 @@
           <a:p>
             <a:br/>
             <a:pPr>
-              <a:defRPr b="1" sz="1050">
+              <a:defRPr b="1" sz="1000">
                 <a:solidFill>
                   <a:srgbClr val="FFFFFF"/>
                 </a:solidFill>
@@ -5372,20 +5372,20 @@
           </a:p>
           <a:p>
             <a:pPr>
-              <a:defRPr sz="900">
+              <a:defRPr sz="850">
                 <a:solidFill>
                   <a:srgbClr val="94A3B8"/>
                 </a:solidFill>
               </a:defRPr>
             </a:pPr>
             <a:r>
-              <a:t>Under EU Markets in Crypto-Assets (MiCA), purely technical non-custodial routers do not hold customer funds and are exempt from CASP licensing.</a:t>
+              <a:t>Under EU MiCA, purely technical non-custodial routers do not hold customer funds and are exempt from CASP licensing.</a:t>
             </a:r>
           </a:p>
           <a:p>
             <a:br/>
             <a:pPr>
-              <a:defRPr b="1" sz="1050">
+              <a:defRPr b="1" sz="1000">
                 <a:solidFill>
                   <a:srgbClr val="FFFFFF"/>
                 </a:solidFill>
@@ -5397,20 +5397,20 @@
           </a:p>
           <a:p>
             <a:pPr>
-              <a:defRPr sz="900">
+              <a:defRPr sz="850">
                 <a:solidFill>
                   <a:srgbClr val="94A3B8"/>
                 </a:solidFill>
               </a:defRPr>
             </a:pPr>
             <a:r>
-              <a:t>Inference prompts and completions are streamed in transit through RAM and never persisted to disk, fully complying with GDPR and EU AI Act Article 50.</a:t>
+              <a:t>Prompts and completions stream in RAM and are never persisted to disk, fully complying with GDPR and EU AI Act Article 50.</a:t>
             </a:r>
           </a:p>
           <a:p>
             <a:br/>
             <a:pPr>
-              <a:defRPr b="1" sz="1050">
+              <a:defRPr b="1" sz="1000">
                 <a:solidFill>
                   <a:srgbClr val="FFFFFF"/>
                 </a:solidFill>
@@ -5422,20 +5422,20 @@
           </a:p>
           <a:p>
             <a:pPr>
-              <a:defRPr sz="900">
+              <a:defRPr sz="850">
                 <a:solidFill>
                   <a:srgbClr val="94A3B8"/>
                 </a:solidFill>
               </a:defRPr>
             </a:pPr>
             <a:r>
-              <a:t>Protocol parameter updates, fee changes, and slashing decisions are governed exclusively by on-chain DAO consensus, avoiding centralized issuer liabilities.</a:t>
+              <a:t>Protocol parameter updates and fee changes are governed on-chain by the DAO, eliminating centralized promoter liabilities.</a:t>
             </a:r>
           </a:p>
           <a:p>
             <a:br/>
             <a:pPr>
-              <a:defRPr b="1" sz="1050">
+              <a:defRPr b="1" sz="1000">
                 <a:solidFill>
                   <a:srgbClr val="FFFFFF"/>
                 </a:solidFill>
@@ -5447,14 +5447,14 @@
           </a:p>
           <a:p>
             <a:pPr>
-              <a:defRPr sz="900">
+              <a:defRPr sz="850">
                 <a:solidFill>
                   <a:srgbClr val="94A3B8"/>
                 </a:solidFill>
               </a:defRPr>
             </a:pPr>
             <a:r>
-              <a:t>Settlements utilize regulated Circle USDC on Arbitrum with verified on-chain proofs and deterministic smart contracts.</a:t>
+              <a:t>Micro-settlements utilize regulated Circle USDC on Arbitrum with verified on-chain proofs and deterministic smart contracts.</a:t>
             </a:r>
           </a:p>
         </p:txBody>
@@ -5699,7 +5699,7 @@
         <p:spPr>
           <a:xfrm>
             <a:off x="548640" y="365760"/>
-            <a:ext cx="11064240" cy="731520"/>
+            <a:ext cx="11064240" cy="777240"/>
           </a:xfrm>
           <a:prstGeom prst="rect">
             <a:avLst/>
@@ -5713,7 +5713,7 @@
           <a:lstStyle/>
           <a:p>
             <a:pPr>
-              <a:defRPr sz="2400" b="1">
+              <a:defRPr sz="2300" b="1">
                 <a:solidFill>
                   <a:srgbClr val="FFFFFF"/>
                 </a:solidFill>
@@ -5726,7 +5726,7 @@
           </a:p>
           <a:p>
             <a:pPr>
-              <a:defRPr sz="1300">
+              <a:defRPr sz="1200">
                 <a:solidFill>
                   <a:srgbClr val="38BDF8"/>
                 </a:solidFill>
@@ -5777,11 +5777,11 @@
           </a:fontRef>
         </p:style>
         <p:txBody>
-          <a:bodyPr rtlCol="0" anchor="ctr" wrap="square" lIns="164592" tIns="164592" rIns="164592" bIns="164592"/>
+          <a:bodyPr rtlCol="0" anchor="ctr" wrap="square" lIns="146304" tIns="146304" rIns="146304" bIns="146304"/>
           <a:lstStyle/>
           <a:p>
             <a:pPr algn="ctr">
-              <a:defRPr b="1" sz="1100">
+              <a:defRPr b="1" sz="1050">
                 <a:solidFill>
                   <a:srgbClr val="34D399"/>
                 </a:solidFill>
@@ -5793,7 +5793,7 @@
           </a:p>
           <a:p>
             <a:pPr>
-              <a:defRPr b="1" sz="950">
+              <a:defRPr b="1" sz="900">
                 <a:solidFill>
                   <a:srgbClr val="FFFFFF"/>
                 </a:solidFill>
@@ -5806,7 +5806,7 @@
           <a:p>
             <a:br/>
             <a:pPr>
-              <a:defRPr b="1" sz="900">
+              <a:defRPr b="1" sz="850">
                 <a:solidFill>
                   <a:srgbClr val="34D399"/>
                 </a:solidFill>
@@ -5818,7 +5818,7 @@
           </a:p>
           <a:p>
             <a:pPr>
-              <a:defRPr sz="850">
+              <a:defRPr sz="800">
                 <a:solidFill>
                   <a:srgbClr val="94A3B8"/>
                 </a:solidFill>
@@ -5831,7 +5831,7 @@
           <a:p>
             <a:br/>
             <a:pPr>
-              <a:defRPr b="1" sz="900">
+              <a:defRPr b="1" sz="850">
                 <a:solidFill>
                   <a:srgbClr val="34D399"/>
                 </a:solidFill>
@@ -5843,7 +5843,7 @@
           </a:p>
           <a:p>
             <a:pPr>
-              <a:defRPr sz="850">
+              <a:defRPr sz="800">
                 <a:solidFill>
                   <a:srgbClr val="94A3B8"/>
                 </a:solidFill>
@@ -5856,7 +5856,7 @@
           <a:p>
             <a:br/>
             <a:pPr>
-              <a:defRPr b="1" sz="900">
+              <a:defRPr b="1" sz="850">
                 <a:solidFill>
                   <a:srgbClr val="34D399"/>
                 </a:solidFill>
@@ -5868,7 +5868,7 @@
           </a:p>
           <a:p>
             <a:pPr>
-              <a:defRPr sz="850">
+              <a:defRPr sz="800">
                 <a:solidFill>
                   <a:srgbClr val="94A3B8"/>
                 </a:solidFill>
@@ -5881,7 +5881,7 @@
           <a:p>
             <a:br/>
             <a:pPr>
-              <a:defRPr b="1" sz="900">
+              <a:defRPr b="1" sz="850">
                 <a:solidFill>
                   <a:srgbClr val="34D399"/>
                 </a:solidFill>
@@ -5893,7 +5893,7 @@
           </a:p>
           <a:p>
             <a:pPr>
-              <a:defRPr sz="850">
+              <a:defRPr sz="800">
                 <a:solidFill>
                   <a:srgbClr val="94A3B8"/>
                 </a:solidFill>
@@ -5906,7 +5906,7 @@
           <a:p>
             <a:br/>
             <a:pPr>
-              <a:defRPr b="1" sz="900">
+              <a:defRPr b="1" sz="850">
                 <a:solidFill>
                   <a:srgbClr val="34D399"/>
                 </a:solidFill>
@@ -5918,7 +5918,7 @@
           </a:p>
           <a:p>
             <a:pPr>
-              <a:defRPr sz="850">
+              <a:defRPr sz="800">
                 <a:solidFill>
                   <a:srgbClr val="94A3B8"/>
                 </a:solidFill>
@@ -5968,11 +5968,11 @@
           </a:fontRef>
         </p:style>
         <p:txBody>
-          <a:bodyPr rtlCol="0" anchor="ctr" wrap="square" lIns="164592" tIns="164592" rIns="164592" bIns="164592"/>
+          <a:bodyPr rtlCol="0" anchor="ctr" wrap="square" lIns="146304" tIns="146304" rIns="146304" bIns="146304"/>
           <a:lstStyle/>
           <a:p>
             <a:pPr algn="ctr">
-              <a:defRPr b="1" sz="1100">
+              <a:defRPr b="1" sz="1050">
                 <a:solidFill>
                   <a:srgbClr val="38BDF8"/>
                 </a:solidFill>
@@ -5984,7 +5984,7 @@
           </a:p>
           <a:p>
             <a:pPr>
-              <a:defRPr b="1" sz="950">
+              <a:defRPr b="1" sz="900">
                 <a:solidFill>
                   <a:srgbClr val="FFFFFF"/>
                 </a:solidFill>
@@ -5997,7 +5997,7 @@
           <a:p>
             <a:br/>
             <a:pPr>
-              <a:defRPr b="1" sz="900">
+              <a:defRPr b="1" sz="850">
                 <a:solidFill>
                   <a:srgbClr val="38BDF8"/>
                 </a:solidFill>
@@ -6009,7 +6009,7 @@
           </a:p>
           <a:p>
             <a:pPr>
-              <a:defRPr sz="850">
+              <a:defRPr sz="800">
                 <a:solidFill>
                   <a:srgbClr val="94A3B8"/>
                 </a:solidFill>
@@ -6022,7 +6022,7 @@
           <a:p>
             <a:br/>
             <a:pPr>
-              <a:defRPr b="1" sz="900">
+              <a:defRPr b="1" sz="850">
                 <a:solidFill>
                   <a:srgbClr val="38BDF8"/>
                 </a:solidFill>
@@ -6034,7 +6034,7 @@
           </a:p>
           <a:p>
             <a:pPr>
-              <a:defRPr sz="850">
+              <a:defRPr sz="800">
                 <a:solidFill>
                   <a:srgbClr val="94A3B8"/>
                 </a:solidFill>
@@ -6047,7 +6047,7 @@
           <a:p>
             <a:br/>
             <a:pPr>
-              <a:defRPr b="1" sz="900">
+              <a:defRPr b="1" sz="850">
                 <a:solidFill>
                   <a:srgbClr val="38BDF8"/>
                 </a:solidFill>
@@ -6059,7 +6059,7 @@
           </a:p>
           <a:p>
             <a:pPr>
-              <a:defRPr sz="850">
+              <a:defRPr sz="800">
                 <a:solidFill>
                   <a:srgbClr val="94A3B8"/>
                 </a:solidFill>
@@ -6072,7 +6072,7 @@
           <a:p>
             <a:br/>
             <a:pPr>
-              <a:defRPr b="1" sz="900">
+              <a:defRPr b="1" sz="850">
                 <a:solidFill>
                   <a:srgbClr val="38BDF8"/>
                 </a:solidFill>
@@ -6084,7 +6084,7 @@
           </a:p>
           <a:p>
             <a:pPr>
-              <a:defRPr sz="850">
+              <a:defRPr sz="800">
                 <a:solidFill>
                   <a:srgbClr val="94A3B8"/>
                 </a:solidFill>
@@ -6097,7 +6097,7 @@
           <a:p>
             <a:br/>
             <a:pPr>
-              <a:defRPr b="1" sz="900">
+              <a:defRPr b="1" sz="850">
                 <a:solidFill>
                   <a:srgbClr val="38BDF8"/>
                 </a:solidFill>
@@ -6109,7 +6109,7 @@
           </a:p>
           <a:p>
             <a:pPr>
-              <a:defRPr sz="850">
+              <a:defRPr sz="800">
                 <a:solidFill>
                   <a:srgbClr val="94A3B8"/>
                 </a:solidFill>
@@ -6159,11 +6159,11 @@
           </a:fontRef>
         </p:style>
         <p:txBody>
-          <a:bodyPr rtlCol="0" anchor="ctr" wrap="square" lIns="164592" tIns="164592" rIns="164592" bIns="164592"/>
+          <a:bodyPr rtlCol="0" anchor="ctr" wrap="square" lIns="146304" tIns="146304" rIns="146304" bIns="146304"/>
           <a:lstStyle/>
           <a:p>
             <a:pPr algn="ctr">
-              <a:defRPr b="1" sz="1100">
+              <a:defRPr b="1" sz="1050">
                 <a:solidFill>
                   <a:srgbClr val="C084FC"/>
                 </a:solidFill>
@@ -6175,7 +6175,7 @@
           </a:p>
           <a:p>
             <a:pPr>
-              <a:defRPr b="1" sz="950">
+              <a:defRPr b="1" sz="900">
                 <a:solidFill>
                   <a:srgbClr val="FFFFFF"/>
                 </a:solidFill>
@@ -6188,7 +6188,7 @@
           <a:p>
             <a:br/>
             <a:pPr>
-              <a:defRPr b="1" sz="900">
+              <a:defRPr b="1" sz="850">
                 <a:solidFill>
                   <a:srgbClr val="C084FC"/>
                 </a:solidFill>
@@ -6200,7 +6200,7 @@
           </a:p>
           <a:p>
             <a:pPr>
-              <a:defRPr sz="850">
+              <a:defRPr sz="800">
                 <a:solidFill>
                   <a:srgbClr val="94A3B8"/>
                 </a:solidFill>
@@ -6213,7 +6213,7 @@
           <a:p>
             <a:br/>
             <a:pPr>
-              <a:defRPr b="1" sz="900">
+              <a:defRPr b="1" sz="850">
                 <a:solidFill>
                   <a:srgbClr val="C084FC"/>
                 </a:solidFill>
@@ -6225,7 +6225,7 @@
           </a:p>
           <a:p>
             <a:pPr>
-              <a:defRPr sz="850">
+              <a:defRPr sz="800">
                 <a:solidFill>
                   <a:srgbClr val="94A3B8"/>
                 </a:solidFill>
@@ -6238,7 +6238,7 @@
           <a:p>
             <a:br/>
             <a:pPr>
-              <a:defRPr b="1" sz="900">
+              <a:defRPr b="1" sz="850">
                 <a:solidFill>
                   <a:srgbClr val="C084FC"/>
                 </a:solidFill>
@@ -6250,7 +6250,7 @@
           </a:p>
           <a:p>
             <a:pPr>
-              <a:defRPr sz="850">
+              <a:defRPr sz="800">
                 <a:solidFill>
                   <a:srgbClr val="94A3B8"/>
                 </a:solidFill>
@@ -6263,7 +6263,7 @@
           <a:p>
             <a:br/>
             <a:pPr>
-              <a:defRPr b="1" sz="900">
+              <a:defRPr b="1" sz="850">
                 <a:solidFill>
                   <a:srgbClr val="C084FC"/>
                 </a:solidFill>
@@ -6275,7 +6275,7 @@
           </a:p>
           <a:p>
             <a:pPr>
-              <a:defRPr sz="850">
+              <a:defRPr sz="800">
                 <a:solidFill>
                   <a:srgbClr val="94A3B8"/>
                 </a:solidFill>
@@ -6288,7 +6288,7 @@
           <a:p>
             <a:br/>
             <a:pPr>
-              <a:defRPr b="1" sz="900">
+              <a:defRPr b="1" sz="850">
                 <a:solidFill>
                   <a:srgbClr val="C084FC"/>
                 </a:solidFill>
@@ -6300,7 +6300,7 @@
           </a:p>
           <a:p>
             <a:pPr>
-              <a:defRPr sz="850">
+              <a:defRPr sz="800">
                 <a:solidFill>
                   <a:srgbClr val="94A3B8"/>
                 </a:solidFill>
@@ -6350,11 +6350,11 @@
           </a:fontRef>
         </p:style>
         <p:txBody>
-          <a:bodyPr rtlCol="0" anchor="ctr" wrap="square" lIns="164592" tIns="164592" rIns="164592" bIns="164592"/>
+          <a:bodyPr rtlCol="0" anchor="ctr" wrap="square" lIns="146304" tIns="146304" rIns="146304" bIns="146304"/>
           <a:lstStyle/>
           <a:p>
             <a:pPr algn="ctr">
-              <a:defRPr b="1" sz="1100">
+              <a:defRPr b="1" sz="1050">
                 <a:solidFill>
                   <a:srgbClr val="FBBF24"/>
                 </a:solidFill>
@@ -6366,7 +6366,7 @@
           </a:p>
           <a:p>
             <a:pPr>
-              <a:defRPr b="1" sz="950">
+              <a:defRPr b="1" sz="900">
                 <a:solidFill>
                   <a:srgbClr val="FFFFFF"/>
                 </a:solidFill>
@@ -6379,7 +6379,7 @@
           <a:p>
             <a:br/>
             <a:pPr>
-              <a:defRPr b="1" sz="900">
+              <a:defRPr b="1" sz="850">
                 <a:solidFill>
                   <a:srgbClr val="FBBF24"/>
                 </a:solidFill>
@@ -6391,7 +6391,7 @@
           </a:p>
           <a:p>
             <a:pPr>
-              <a:defRPr sz="850">
+              <a:defRPr sz="800">
                 <a:solidFill>
                   <a:srgbClr val="94A3B8"/>
                 </a:solidFill>
@@ -6404,7 +6404,7 @@
           <a:p>
             <a:br/>
             <a:pPr>
-              <a:defRPr b="1" sz="900">
+              <a:defRPr b="1" sz="850">
                 <a:solidFill>
                   <a:srgbClr val="FBBF24"/>
                 </a:solidFill>
@@ -6416,7 +6416,7 @@
           </a:p>
           <a:p>
             <a:pPr>
-              <a:defRPr sz="850">
+              <a:defRPr sz="800">
                 <a:solidFill>
                   <a:srgbClr val="94A3B8"/>
                 </a:solidFill>
@@ -6429,7 +6429,7 @@
           <a:p>
             <a:br/>
             <a:pPr>
-              <a:defRPr b="1" sz="900">
+              <a:defRPr b="1" sz="850">
                 <a:solidFill>
                   <a:srgbClr val="FBBF24"/>
                 </a:solidFill>
@@ -6441,7 +6441,7 @@
           </a:p>
           <a:p>
             <a:pPr>
-              <a:defRPr sz="850">
+              <a:defRPr sz="800">
                 <a:solidFill>
                   <a:srgbClr val="94A3B8"/>
                 </a:solidFill>
@@ -6454,7 +6454,7 @@
           <a:p>
             <a:br/>
             <a:pPr>
-              <a:defRPr b="1" sz="900">
+              <a:defRPr b="1" sz="850">
                 <a:solidFill>
                   <a:srgbClr val="FBBF24"/>
                 </a:solidFill>
@@ -6466,7 +6466,7 @@
           </a:p>
           <a:p>
             <a:pPr>
-              <a:defRPr sz="850">
+              <a:defRPr sz="800">
                 <a:solidFill>
                   <a:srgbClr val="94A3B8"/>
                 </a:solidFill>
@@ -6479,7 +6479,7 @@
           <a:p>
             <a:br/>
             <a:pPr>
-              <a:defRPr b="1" sz="900">
+              <a:defRPr b="1" sz="850">
                 <a:solidFill>
                   <a:srgbClr val="FBBF24"/>
                 </a:solidFill>
@@ -6491,7 +6491,7 @@
           </a:p>
           <a:p>
             <a:pPr>
-              <a:defRPr sz="850">
+              <a:defRPr sz="800">
                 <a:solidFill>
                   <a:srgbClr val="94A3B8"/>
                 </a:solidFill>
@@ -6657,7 +6657,7 @@
               </a:defRPr>
             </a:pPr>
             <a:r>
-              <a:t>Presenter: Simon Havlík (havlik.simon@post.cz)</a:t>
+              <a:t>Presenter: Šimon Havlík (havlik.simon@post.cz)</a:t>
             </a:r>
             <a:br/>
             <a:r>
@@ -6665,7 +6665,7 @@
             </a:r>
             <a:br/>
             <a:r>
-              <a:t>Prague University of Economics and Business (VŠE)</a:t>
+              <a:t>Prague University of Economics and Business (VŠE Praha)</a:t>
             </a:r>
           </a:p>
         </p:txBody>
@@ -6910,7 +6910,7 @@
         <p:spPr>
           <a:xfrm>
             <a:off x="548640" y="365760"/>
-            <a:ext cx="11064240" cy="731520"/>
+            <a:ext cx="11064240" cy="777240"/>
           </a:xfrm>
           <a:prstGeom prst="rect">
             <a:avLst/>
@@ -6924,7 +6924,7 @@
           <a:lstStyle/>
           <a:p>
             <a:pPr>
-              <a:defRPr sz="2400" b="1">
+              <a:defRPr sz="2300" b="1">
                 <a:solidFill>
                   <a:srgbClr val="FFFFFF"/>
                 </a:solidFill>
@@ -6937,7 +6937,7 @@
           </a:p>
           <a:p>
             <a:pPr>
-              <a:defRPr sz="1300">
+              <a:defRPr sz="1200">
                 <a:solidFill>
                   <a:srgbClr val="38BDF8"/>
                 </a:solidFill>
@@ -6945,7 +6945,7 @@
               </a:defRPr>
             </a:pPr>
             <a:r>
-              <a:t>Why centralized AI gateways are rent-seeking tollbooths and how Verxl fixes it</a:t>
+              <a:t>Centralized AI gateways are rent-seeking tollbooths holding back compute liquidity</a:t>
             </a:r>
           </a:p>
         </p:txBody>
@@ -6988,11 +6988,11 @@
           </a:fontRef>
         </p:style>
         <p:txBody>
-          <a:bodyPr rtlCol="0" anchor="ctr" wrap="square" lIns="228600" tIns="228600" rIns="228600" bIns="228600"/>
+          <a:bodyPr rtlCol="0" anchor="ctr" wrap="square" lIns="201168" tIns="201168" rIns="201168" bIns="201168"/>
           <a:lstStyle/>
           <a:p>
             <a:pPr algn="ctr">
-              <a:defRPr b="1" sz="1400">
+              <a:defRPr b="1" sz="1350">
                 <a:solidFill>
                   <a:srgbClr val="F87171"/>
                 </a:solidFill>
@@ -7005,57 +7005,57 @@
           <a:p>
             <a:br/>
             <a:pPr>
-              <a:defRPr b="1" sz="1100">
+              <a:defRPr b="1" sz="1050">
                 <a:solidFill>
                   <a:srgbClr val="FFFFFF"/>
                 </a:solidFill>
               </a:defRPr>
             </a:pPr>
             <a:r>
-              <a:t>• 80–90% Gross Margin Markup</a:t>
-            </a:r>
-          </a:p>
-          <a:p>
-            <a:pPr>
-              <a:defRPr sz="950">
+              <a:t>• 80–90% Gross Margin Markups</a:t>
+            </a:r>
+          </a:p>
+          <a:p>
+            <a:pPr>
+              <a:defRPr sz="900">
                 <a:solidFill>
                   <a:srgbClr val="94A3B8"/>
                 </a:solidFill>
               </a:defRPr>
             </a:pPr>
             <a:r>
-              <a:t>Centralized providers (OpenAI, AWS Bedrock) add massive rent-seeking spreads on top of raw GPU compute.</a:t>
+              <a:t>AWS Bedrock and OpenAI extract massive markups on commodity open-source models (DeepSeek, Qwen).</a:t>
             </a:r>
           </a:p>
           <a:p>
             <a:br/>
             <a:pPr>
-              <a:defRPr b="1" sz="1100">
+              <a:defRPr b="1" sz="1050">
                 <a:solidFill>
                   <a:srgbClr val="FFFFFF"/>
                 </a:solidFill>
               </a:defRPr>
             </a:pPr>
             <a:r>
-              <a:t>• Walled Gardens &amp; Vendor Lock-In</a:t>
-            </a:r>
-          </a:p>
-          <a:p>
-            <a:pPr>
-              <a:defRPr sz="950">
+              <a:t>• Walled Gardens &amp; Account Freezes</a:t>
+            </a:r>
+          </a:p>
+          <a:p>
+            <a:pPr>
+              <a:defRPr sz="900">
                 <a:solidFill>
                   <a:srgbClr val="94A3B8"/>
                 </a:solidFill>
               </a:defRPr>
             </a:pPr>
             <a:r>
-              <a:t>Strict proprietary SDKs, account suspensions without appeal, and enforced credit card subscriptions.</a:t>
+              <a:t>Strict proprietary SDKs, arbitrary developer account freezes without appeal, and mandatory credit subscriptions.</a:t>
             </a:r>
           </a:p>
           <a:p>
             <a:br/>
             <a:pPr>
-              <a:defRPr b="1" sz="1100">
+              <a:defRPr b="1" sz="1050">
                 <a:solidFill>
                   <a:srgbClr val="FFFFFF"/>
                 </a:solidFill>
@@ -7067,14 +7067,14 @@
           </a:p>
           <a:p>
             <a:pPr>
-              <a:defRPr sz="950">
+              <a:defRPr sz="900">
                 <a:solidFill>
                   <a:srgbClr val="94A3B8"/>
                 </a:solidFill>
               </a:defRPr>
             </a:pPr>
             <a:r>
-              <a:t>Developers must submit passports, corporate registry documents, and phone numbers to run open weights.</a:t>
+              <a:t>Developers must submit passports, corporate documents, and phone numbers to run open weights.</a:t>
             </a:r>
           </a:p>
         </p:txBody>
@@ -7117,49 +7117,49 @@
           </a:fontRef>
         </p:style>
         <p:txBody>
-          <a:bodyPr rtlCol="0" anchor="ctr" wrap="square" lIns="228600" tIns="228600" rIns="228600" bIns="228600"/>
+          <a:bodyPr rtlCol="0" anchor="ctr" wrap="square" lIns="201168" tIns="201168" rIns="201168" bIns="201168"/>
           <a:lstStyle/>
           <a:p>
             <a:pPr algn="ctr">
-              <a:defRPr b="1" sz="1400">
+              <a:defRPr b="1" sz="1350">
                 <a:solidFill>
                   <a:srgbClr val="FBBF24"/>
                 </a:solidFill>
               </a:defRPr>
             </a:pPr>
             <a:r>
-              <a:t>⚡ IDLE COMPUTE DILEMMA</a:t>
+              <a:t>⚡ IDLE COMPUTE BOTTLENECK</a:t>
             </a:r>
           </a:p>
           <a:p>
             <a:br/>
             <a:pPr>
-              <a:defRPr b="1" sz="1100">
+              <a:defRPr b="1" sz="1050">
                 <a:solidFill>
                   <a:srgbClr val="FFFFFF"/>
                 </a:solidFill>
               </a:defRPr>
             </a:pPr>
             <a:r>
-              <a:t>• Massive Unmonetized Clusters</a:t>
-            </a:r>
-          </a:p>
-          <a:p>
-            <a:pPr>
-              <a:defRPr sz="950">
+              <a:t>• Thousands of Idle GPUs</a:t>
+            </a:r>
+          </a:p>
+          <a:p>
+            <a:pPr>
+              <a:defRPr sz="900">
                 <a:solidFill>
                   <a:srgbClr val="94A3B8"/>
                 </a:solidFill>
               </a:defRPr>
             </a:pPr>
             <a:r>
-              <a:t>Regional datacenters and miners sit on thousands of H100s, A100s, and 4090s with zero retail access.</a:t>
+              <a:t>Regional European and Asian datacenters hold unmonetized H100 and A100 clusters with zero retail distribution.</a:t>
             </a:r>
           </a:p>
           <a:p>
             <a:br/>
             <a:pPr>
-              <a:defRPr b="1" sz="1100">
+              <a:defRPr b="1" sz="1050">
                 <a:solidFill>
                   <a:srgbClr val="FFFFFF"/>
                 </a:solidFill>
@@ -7171,32 +7171,32 @@
           </a:p>
           <a:p>
             <a:pPr>
-              <a:defRPr sz="950">
+              <a:defRPr sz="900">
                 <a:solidFill>
                   <a:srgbClr val="94A3B8"/>
                 </a:solidFill>
               </a:defRPr>
             </a:pPr>
             <a:r>
-              <a:t>No permissionless way to aggregate disparate compute nodes into a reliable single API endpoint.</a:t>
+              <a:t>No unified, permissionless mechanism to aggregate distributed hardware into one high-availability endpoint.</a:t>
             </a:r>
           </a:p>
           <a:p>
             <a:br/>
             <a:pPr>
-              <a:defRPr b="1" sz="1100">
+              <a:defRPr b="1" sz="1050">
                 <a:solidFill>
                   <a:srgbClr val="FFFFFF"/>
                 </a:solidFill>
               </a:defRPr>
             </a:pPr>
             <a:r>
-              <a:t>• Payment Delay Friction</a:t>
-            </a:r>
-          </a:p>
-          <a:p>
-            <a:pPr>
-              <a:defRPr sz="950">
+              <a:t>• 30-Day Payment Friction</a:t>
+            </a:r>
+          </a:p>
+          <a:p>
+            <a:pPr>
+              <a:defRPr sz="900">
                 <a:solidFill>
                   <a:srgbClr val="94A3B8"/>
                 </a:solidFill>
@@ -7246,11 +7246,11 @@
           </a:fontRef>
         </p:style>
         <p:txBody>
-          <a:bodyPr rtlCol="0" anchor="ctr" wrap="square" lIns="228600" tIns="228600" rIns="228600" bIns="228600"/>
+          <a:bodyPr rtlCol="0" anchor="ctr" wrap="square" lIns="201168" tIns="201168" rIns="201168" bIns="201168"/>
           <a:lstStyle/>
           <a:p>
             <a:pPr algn="ctr">
-              <a:defRPr b="1" sz="1400">
+              <a:defRPr b="1" sz="1350">
                 <a:solidFill>
                   <a:srgbClr val="34D399"/>
                 </a:solidFill>
@@ -7263,7 +7263,7 @@
           <a:p>
             <a:br/>
             <a:pPr>
-              <a:defRPr b="1" sz="1100">
+              <a:defRPr b="1" sz="1050">
                 <a:solidFill>
                   <a:srgbClr val="FFFFFF"/>
                 </a:solidFill>
@@ -7275,64 +7275,64 @@
           </a:p>
           <a:p>
             <a:pPr>
-              <a:defRPr sz="950">
+              <a:defRPr sz="900">
                 <a:solidFill>
                   <a:srgbClr val="94A3B8"/>
                 </a:solidFill>
               </a:defRPr>
             </a:pPr>
             <a:r>
-              <a:t>Non-custodial edge router charges only 0.5% protocol spread — saving developers over 94% on fees.</a:t>
+              <a:t>Non-custodial edge router charges only 0.5% protocol spread — saving developers over 94% on fee markups.</a:t>
             </a:r>
           </a:p>
           <a:p>
             <a:br/>
             <a:pPr>
-              <a:defRPr b="1" sz="1100">
+              <a:defRPr b="1" sz="1050">
                 <a:solidFill>
                   <a:srgbClr val="FFFFFF"/>
                 </a:solidFill>
               </a:defRPr>
             </a:pPr>
             <a:r>
-              <a:t>• Drop-in OpenAI Compatibility</a:t>
-            </a:r>
-          </a:p>
-          <a:p>
-            <a:pPr>
-              <a:defRPr sz="950">
+              <a:t>• OpenAI Drop-In Compatibility</a:t>
+            </a:r>
+          </a:p>
+          <a:p>
+            <a:pPr>
+              <a:defRPr sz="900">
                 <a:solidFill>
                   <a:srgbClr val="94A3B8"/>
                 </a:solidFill>
               </a:defRPr>
             </a:pPr>
             <a:r>
-              <a:t>Standard endpoint (`api.verxl.com/v1`). Any existing AI codebase runs with zero code changes.</a:t>
+              <a:t>Standard endpoint (`api.verxl.com/v1`). Any existing AI codebase runs with zero code modifications.</a:t>
             </a:r>
           </a:p>
           <a:p>
             <a:br/>
             <a:pPr>
-              <a:defRPr b="1" sz="1100">
+              <a:defRPr b="1" sz="1050">
                 <a:solidFill>
                   <a:srgbClr val="FFFFFF"/>
                 </a:solidFill>
               </a:defRPr>
             </a:pPr>
             <a:r>
-              <a:t>• Instant L2 Settlement</a:t>
-            </a:r>
-          </a:p>
-          <a:p>
-            <a:pPr>
-              <a:defRPr sz="950">
+              <a:t>• Instant L2 Micro-Settlements</a:t>
+            </a:r>
+          </a:p>
+          <a:p>
+            <a:pPr>
+              <a:defRPr sz="900">
                 <a:solidFill>
                   <a:srgbClr val="94A3B8"/>
                 </a:solidFill>
               </a:defRPr>
             </a:pPr>
             <a:r>
-              <a:t>Arbitrum L2 micro-settlements (&lt;$0.01 gas fee) allow compute nodes to withdraw earnings in seconds.</a:t>
+              <a:t>Arbitrum L2 settlements (&lt;$0.01 gas fee) allow compute nodes to withdraw earnings in seconds in USDC.</a:t>
             </a:r>
           </a:p>
         </p:txBody>
@@ -7577,7 +7577,7 @@
         <p:spPr>
           <a:xfrm>
             <a:off x="548640" y="365760"/>
-            <a:ext cx="11064240" cy="731520"/>
+            <a:ext cx="11064240" cy="777240"/>
           </a:xfrm>
           <a:prstGeom prst="rect">
             <a:avLst/>
@@ -7591,7 +7591,7 @@
           <a:lstStyle/>
           <a:p>
             <a:pPr>
-              <a:defRPr sz="2400" b="1">
+              <a:defRPr sz="2300" b="1">
                 <a:solidFill>
                   <a:srgbClr val="FFFFFF"/>
                 </a:solidFill>
@@ -7604,7 +7604,7 @@
           </a:p>
           <a:p>
             <a:pPr>
-              <a:defRPr sz="1300">
+              <a:defRPr sz="1200">
                 <a:solidFill>
                   <a:srgbClr val="38BDF8"/>
                 </a:solidFill>
@@ -7612,7 +7612,7 @@
               </a:defRPr>
             </a:pPr>
             <a:r>
-              <a:t>Why crypto developers are the ideal, low-CAC customer acquisition engine</a:t>
+              <a:t>High-conviction, low-CAC customer acquisition engine leveraging on-chain incentives</a:t>
             </a:r>
           </a:p>
         </p:txBody>
@@ -7626,7 +7626,7 @@
         <p:spPr>
           <a:xfrm>
             <a:off x="548640" y="1371600"/>
-            <a:ext cx="10789920" cy="1234440"/>
+            <a:ext cx="10789920" cy="1188720"/>
           </a:xfrm>
           <a:prstGeom prst="roundRect">
             <a:avLst/>
@@ -7655,11 +7655,11 @@
           </a:fontRef>
         </p:style>
         <p:txBody>
-          <a:bodyPr rtlCol="0" anchor="ctr" wrap="square" lIns="164592" tIns="164592" rIns="164592" bIns="164592"/>
+          <a:bodyPr rtlCol="0" anchor="ctr" wrap="square" lIns="146304" tIns="146304" rIns="146304" bIns="146304"/>
           <a:lstStyle/>
           <a:p>
             <a:pPr algn="ctr">
-              <a:defRPr b="1" sz="1200">
+              <a:defRPr b="1" sz="1150">
                 <a:solidFill>
                   <a:srgbClr val="38BDF8"/>
                 </a:solidFill>
@@ -7671,14 +7671,14 @@
           </a:p>
           <a:p>
             <a:pPr>
-              <a:defRPr sz="1000">
+              <a:defRPr sz="950">
                 <a:solidFill>
                   <a:srgbClr val="FFFFFF"/>
                 </a:solidFill>
               </a:defRPr>
             </a:pPr>
             <a:r>
-              <a:t>Autonomous Agent Builders &amp; Algorithmic Quants — Developers who build AI trading bots, autonomous assistants (OMP, Hermes), and automated pipelines. They demand raw speed, curl/TypeScript compatibility, and zero UI bloat.</a:t>
+              <a:t>Autonomous Agent Builders &amp; Algorithmic Quants — Developers building AI trading bots, autonomous agents (OMP, Hermes), and automated pipelines. They demand raw speed, curl/TypeScript compatibility, and zero UI bloat.</a:t>
             </a:r>
           </a:p>
         </p:txBody>
@@ -7691,8 +7691,8 @@
         </p:nvSpPr>
         <p:spPr>
           <a:xfrm>
-            <a:off x="548640" y="2743200"/>
-            <a:ext cx="10789920" cy="1234440"/>
+            <a:off x="548640" y="2670048"/>
+            <a:ext cx="10789920" cy="1188720"/>
           </a:xfrm>
           <a:prstGeom prst="roundRect">
             <a:avLst/>
@@ -7721,11 +7721,11 @@
           </a:fontRef>
         </p:style>
         <p:txBody>
-          <a:bodyPr rtlCol="0" anchor="ctr" wrap="square" lIns="164592" tIns="164592" rIns="164592" bIns="164592"/>
+          <a:bodyPr rtlCol="0" anchor="ctr" wrap="square" lIns="146304" tIns="146304" rIns="146304" bIns="146304"/>
           <a:lstStyle/>
           <a:p>
             <a:pPr algn="ctr">
-              <a:defRPr b="1" sz="1200">
+              <a:defRPr b="1" sz="1150">
                 <a:solidFill>
                   <a:srgbClr val="34D399"/>
                 </a:solidFill>
@@ -7737,14 +7737,14 @@
           </a:p>
           <a:p>
             <a:pPr>
-              <a:defRPr sz="1000">
+              <a:defRPr sz="950">
                 <a:solidFill>
                   <a:srgbClr val="FFFFFF"/>
                 </a:solidFill>
               </a:defRPr>
             </a:pPr>
             <a:r>
-              <a:t>Confidential Compute &amp; Freedom of Speech — Users running proprietary financial algorithms or private data who cannot allow OpenAI to train on their prompts. Verxl offers stateless edge execution with zero prompt retention.</a:t>
+              <a:t>Confidential Compute &amp; Freedom of Speech — European fintech quants, researchers, and enterprises who cannot legally permit OpenAI or Microsoft to train on proprietary prompts. Verxl streams data through RAM with zero prompt retention.</a:t>
             </a:r>
           </a:p>
         </p:txBody>
@@ -7757,8 +7757,8 @@
         </p:nvSpPr>
         <p:spPr>
           <a:xfrm>
-            <a:off x="548640" y="4114800"/>
-            <a:ext cx="10789920" cy="1234440"/>
+            <a:off x="548640" y="3968496"/>
+            <a:ext cx="10789920" cy="1188720"/>
           </a:xfrm>
           <a:prstGeom prst="roundRect">
             <a:avLst/>
@@ -7787,30 +7787,30 @@
           </a:fontRef>
         </p:style>
         <p:txBody>
-          <a:bodyPr rtlCol="0" anchor="ctr" wrap="square" lIns="164592" tIns="164592" rIns="164592" bIns="164592"/>
+          <a:bodyPr rtlCol="0" anchor="ctr" wrap="square" lIns="146304" tIns="146304" rIns="146304" bIns="146304"/>
           <a:lstStyle/>
           <a:p>
             <a:pPr algn="ctr">
-              <a:defRPr b="1" sz="1200">
+              <a:defRPr b="1" sz="1150">
                 <a:solidFill>
                   <a:srgbClr val="C084FC"/>
                 </a:solidFill>
               </a:defRPr>
             </a:pPr>
             <a:r>
-              <a:t>3. ON-CHAIN IDENTIFIABLE COMMUNITY &amp; VIRAL CAMPAIGNS</a:t>
-            </a:r>
-          </a:p>
-          <a:p>
-            <a:pPr>
-              <a:defRPr sz="1000">
+              <a:t>3. ON-CHAIN IDENTIFIABLE COMMUNITY</a:t>
+            </a:r>
+          </a:p>
+          <a:p>
+            <a:pPr>
+              <a:defRPr sz="950">
                 <a:solidFill>
                   <a:srgbClr val="FFFFFF"/>
                 </a:solidFill>
               </a:defRPr>
             </a:pPr>
             <a:r>
-              <a:t>Low CAC Customer Engine &amp; Token Alignment — Crypto-natives actively seek permissionless protocols. Transparent on-chain volume creates viral engagement, staking rewards, and verifiable protocol metrics with near-zero CAC.</a:t>
+              <a:t>Low CAC Customer Engine &amp; Token Alignment — Crypto-native developers actively seeking decentralized alternatives. Transparent on-chain volume drives viral adoption and staking alignment with near-zero CAC.</a:t>
             </a:r>
           </a:p>
         </p:txBody>
@@ -7823,7 +7823,7 @@
         </p:nvSpPr>
         <p:spPr>
           <a:xfrm>
-            <a:off x="548640" y="5257800"/>
+            <a:off x="548640" y="5303520"/>
             <a:ext cx="10789920" cy="777240"/>
           </a:xfrm>
           <a:prstGeom prst="rect">
@@ -7876,7 +7876,7 @@
               </a:defRPr>
             </a:pPr>
             <a:r>
-              <a:t>Traditional SaaS companies burn $100+ per customer on Google Ads. Verxl leverages on-chain incentive mechanics: L2 liquidity mining and verifiable volume campaigns produce an effective CAC near $0 while compounding Lifetime Value (LTV) on every inference call.</a:t>
+              <a:t>Traditional SaaS companies burn $150+ per customer on Google Ads. Verxl leverages on-chain incentive mechanics: direct 94% fee savings and transparent volume produce an effective CAC near $0 with a projected 25.9x LTV/CAC ratio.</a:t>
             </a:r>
           </a:p>
         </p:txBody>
@@ -8122,7 +8122,7 @@
         <p:spPr>
           <a:xfrm>
             <a:off x="548640" y="365760"/>
-            <a:ext cx="11064240" cy="731520"/>
+            <a:ext cx="11064240" cy="777240"/>
           </a:xfrm>
           <a:prstGeom prst="rect">
             <a:avLst/>
@@ -8136,7 +8136,7 @@
           <a:lstStyle/>
           <a:p>
             <a:pPr>
-              <a:defRPr sz="2400" b="1">
+              <a:defRPr sz="2300" b="1">
                 <a:solidFill>
                   <a:srgbClr val="FFFFFF"/>
                 </a:solidFill>
@@ -8144,12 +8144,12 @@
               </a:defRPr>
             </a:pPr>
             <a:r>
-              <a:t>What is My Role in the Project?</a:t>
-            </a:r>
-          </a:p>
-          <a:p>
-            <a:pPr>
-              <a:defRPr sz="1300">
+              <a:t>Technical Architecture &amp; Core Protocol Engine</a:t>
+            </a:r>
+          </a:p>
+          <a:p>
+            <a:pPr>
+              <a:defRPr sz="1200">
                 <a:solidFill>
                   <a:srgbClr val="38BDF8"/>
                 </a:solidFill>
@@ -8157,21 +8157,75 @@
               </a:defRPr>
             </a:pPr>
             <a:r>
-              <a:t>Founder, Lead Quantitative Systems Designer &amp; Full-Stack Protocol Engineer</a:t>
-            </a:r>
-          </a:p>
-        </p:txBody>
-      </p:sp>
-      <p:sp>
-        <p:nvSpPr>
-          <p:cNvPr id="6" name="Rounded Rectangle 5"/>
+              <a:t>Engineered by Šimon Havlík (Lead Architect) · Academic Collaboration with VŠE Partners</a:t>
+            </a:r>
+          </a:p>
+        </p:txBody>
+      </p:sp>
+      <p:sp>
+        <p:nvSpPr>
+          <p:cNvPr id="6" name="Rectangle 5"/>
           <p:cNvSpPr/>
           <p:nvPr/>
         </p:nvSpPr>
         <p:spPr>
           <a:xfrm>
-            <a:off x="548640" y="1371600"/>
-            <a:ext cx="5257800" cy="2148840"/>
+            <a:off x="548640" y="1298448"/>
+            <a:ext cx="10789920" cy="438912"/>
+          </a:xfrm>
+          <a:prstGeom prst="rect">
+            <a:avLst/>
+          </a:prstGeom>
+          <a:solidFill>
+            <a:srgbClr val="101A2A"/>
+          </a:solidFill>
+          <a:ln w="12700">
+            <a:solidFill>
+              <a:srgbClr val="38BDF8"/>
+            </a:solidFill>
+          </a:ln>
+        </p:spPr>
+        <p:style>
+          <a:lnRef idx="1">
+            <a:schemeClr val="accent1"/>
+          </a:lnRef>
+          <a:fillRef idx="3">
+            <a:schemeClr val="accent1"/>
+          </a:fillRef>
+          <a:effectRef idx="2">
+            <a:schemeClr val="accent1"/>
+          </a:effectRef>
+          <a:fontRef idx="minor">
+            <a:schemeClr val="lt1"/>
+          </a:fontRef>
+        </p:style>
+        <p:txBody>
+          <a:bodyPr rtlCol="0" anchor="ctr" wrap="square" lIns="73152" tIns="73152" rIns="73152" bIns="73152"/>
+          <a:lstStyle/>
+          <a:p>
+            <a:pPr algn="ctr">
+              <a:defRPr b="1" sz="1000">
+                <a:solidFill>
+                  <a:srgbClr val="38BDF8"/>
+                </a:solidFill>
+              </a:defRPr>
+            </a:pPr>
+            <a:r>
+              <a:t>👥 CORE TEAM: Šimon Havlík (Lead Protocol Architect &amp; Full-Stack Developer)  |  Academic Project Partners: VŠE Praha</a:t>
+            </a:r>
+          </a:p>
+        </p:txBody>
+      </p:sp>
+      <p:sp>
+        <p:nvSpPr>
+          <p:cNvPr id="7" name="Rounded Rectangle 6"/>
+          <p:cNvSpPr/>
+          <p:nvPr/>
+        </p:nvSpPr>
+        <p:spPr>
+          <a:xfrm>
+            <a:off x="548640" y="1874519"/>
+            <a:ext cx="5257800" cy="2057400"/>
           </a:xfrm>
           <a:prstGeom prst="roundRect">
             <a:avLst/>
@@ -8200,11 +8254,11 @@
           </a:fontRef>
         </p:style>
         <p:txBody>
-          <a:bodyPr rtlCol="0" anchor="ctr" wrap="square" lIns="164592" tIns="164592" rIns="164592" bIns="164592"/>
+          <a:bodyPr rtlCol="0" anchor="ctr" wrap="square" lIns="146304" tIns="146304" rIns="146304" bIns="146304"/>
           <a:lstStyle/>
           <a:p>
             <a:pPr algn="ctr">
-              <a:defRPr b="1" sz="1100">
+              <a:defRPr b="1" sz="1050">
                 <a:solidFill>
                   <a:srgbClr val="38BDF8"/>
                 </a:solidFill>
@@ -8223,7 +8277,7 @@
               </a:defRPr>
             </a:pPr>
             <a:r>
-              <a:t>• Aragon OSx On-Chain DAO: Engineered and deployed modular DAO governance contracts on Ethereum Sepolia and Arbitrum One.</a:t>
+              <a:t>• Aragon OSx On-Chain DAO: Modular governance contracts deployed on Arbitrum One governing protocol parameters.</a:t>
             </a:r>
           </a:p>
           <a:p>
@@ -8235,7 +8289,7 @@
               </a:defRPr>
             </a:pPr>
             <a:r>
-              <a:t>• Tokenomics &amp; Staking Vault: Designed $VRXL genesis distribution, provider slashing mechanisms (10% slashed on SLA failure), and unbonding cooldowns.</a:t>
+              <a:t>• Tokenomics &amp; Staking Vault: 1,000 $VRXL provider collateral requirement with automated 10% penalty slashes on SLA violations.</a:t>
             </a:r>
           </a:p>
           <a:p>
@@ -8247,21 +8301,21 @@
               </a:defRPr>
             </a:pPr>
             <a:r>
-              <a:t>• Non-Custodial Escrow: Direct smart-contract deposits ensuring protocol operators never hold user private keys or pooled funds.</a:t>
-            </a:r>
-          </a:p>
-        </p:txBody>
-      </p:sp>
-      <p:sp>
-        <p:nvSpPr>
-          <p:cNvPr id="7" name="Rounded Rectangle 6"/>
+              <a:t>• Non-Custodial Escrow: Direct smart-contract deposits ensuring protocol operators never custody user funds.</a:t>
+            </a:r>
+          </a:p>
+        </p:txBody>
+      </p:sp>
+      <p:sp>
+        <p:nvSpPr>
+          <p:cNvPr id="8" name="Rounded Rectangle 7"/>
           <p:cNvSpPr/>
           <p:nvPr/>
         </p:nvSpPr>
         <p:spPr>
           <a:xfrm>
-            <a:off x="6080760" y="1371600"/>
-            <a:ext cx="5257800" cy="2148840"/>
+            <a:off x="6080760" y="1874519"/>
+            <a:ext cx="5257800" cy="2057400"/>
           </a:xfrm>
           <a:prstGeom prst="roundRect">
             <a:avLst/>
@@ -8290,11 +8344,11 @@
           </a:fontRef>
         </p:style>
         <p:txBody>
-          <a:bodyPr rtlCol="0" anchor="ctr" wrap="square" lIns="164592" tIns="164592" rIns="164592" bIns="164592"/>
+          <a:bodyPr rtlCol="0" anchor="ctr" wrap="square" lIns="146304" tIns="146304" rIns="146304" bIns="146304"/>
           <a:lstStyle/>
           <a:p>
             <a:pPr algn="ctr">
-              <a:defRPr b="1" sz="1100">
+              <a:defRPr b="1" sz="1050">
                 <a:solidFill>
                   <a:srgbClr val="34D399"/>
                 </a:solidFill>
@@ -8313,7 +8367,7 @@
               </a:defRPr>
             </a:pPr>
             <a:r>
-              <a:t>• Sub-4ms Edge Routing: Engineered Cloudflare Pages Functions / edge workers that dynamically inspect tokens and route to lowest-latency nodes.</a:t>
+              <a:t>• Sub-4ms Edge Routing: Cloudflare Pages Functions inspecting headers and dynamically dispatching to lowest-latency clusters.</a:t>
             </a:r>
           </a:p>
           <a:p>
@@ -8325,7 +8379,7 @@
               </a:defRPr>
             </a:pPr>
             <a:r>
-              <a:t>• Seed=42 Canary SLA Probing: Built autonomous quality audits: deterministic canary probes verify output integrity in under 200ms.</a:t>
+              <a:t>• Stateless RAM Streaming: Prompts and completions stream in RAM with zero disk persistence, guaranteeing GDPR compliance.</a:t>
             </a:r>
           </a:p>
           <a:p>
@@ -8337,21 +8391,21 @@
               </a:defRPr>
             </a:pPr>
             <a:r>
-              <a:t>• Multi-Provider Fallback: Automated failover between bare-metal clusters and distributed API bridges with zero client interruption.</a:t>
-            </a:r>
-          </a:p>
-        </p:txBody>
-      </p:sp>
-      <p:sp>
-        <p:nvSpPr>
-          <p:cNvPr id="8" name="Rounded Rectangle 7"/>
+              <a:t>• Automated Multi-Node Failover: Sub-second heartbeat health checks reroute inference queries instantly if a node drops offline.</a:t>
+            </a:r>
+          </a:p>
+        </p:txBody>
+      </p:sp>
+      <p:sp>
+        <p:nvSpPr>
+          <p:cNvPr id="9" name="Rounded Rectangle 8"/>
           <p:cNvSpPr/>
           <p:nvPr/>
         </p:nvSpPr>
         <p:spPr>
           <a:xfrm>
-            <a:off x="548640" y="3657600"/>
-            <a:ext cx="5257800" cy="2148840"/>
+            <a:off x="548640" y="4069080"/>
+            <a:ext cx="5257800" cy="2057400"/>
           </a:xfrm>
           <a:prstGeom prst="roundRect">
             <a:avLst/>
@@ -8380,18 +8434,18 @@
           </a:fontRef>
         </p:style>
         <p:txBody>
-          <a:bodyPr rtlCol="0" anchor="ctr" wrap="square" lIns="164592" tIns="164592" rIns="164592" bIns="164592"/>
+          <a:bodyPr rtlCol="0" anchor="ctr" wrap="square" lIns="146304" tIns="146304" rIns="146304" bIns="146304"/>
           <a:lstStyle/>
           <a:p>
             <a:pPr algn="ctr">
-              <a:defRPr b="1" sz="1100">
+              <a:defRPr b="1" sz="1050">
                 <a:solidFill>
                   <a:srgbClr val="FBBF24"/>
                 </a:solidFill>
               </a:defRPr>
             </a:pPr>
             <a:r>
-              <a:t>3. FINANCIAL DATABASE &amp; CRYPTOGRAPHIC SECURITY</a:t>
+              <a:t>3. DETERMINISTIC CANARY QUALITY ORACLE</a:t>
             </a:r>
           </a:p>
           <a:p>
@@ -8403,7 +8457,7 @@
               </a:defRPr>
             </a:pPr>
             <a:r>
-              <a:t>• Charizard PostgreSQL Ledger: Designed strict schema-isolated ledger (`verxl.*`) with zero collision risk against production databases.</a:t>
+              <a:t>• Seed=42 SLA Audits: Autonomous background oracle sends deterministic canary prompts every 60s verifying output authenticity.</a:t>
             </a:r>
           </a:p>
           <a:p>
@@ -8415,7 +8469,7 @@
               </a:defRPr>
             </a:pPr>
             <a:r>
-              <a:t>• RFC 6238 TOTP 2FA Infrastructure: Implemented PBKDF2 password hashing (100k rounds), pure WebCrypto TOTP validation, and 8 one-time recovery codes.</a:t>
+              <a:t>• Sub-200ms Verification: Instantly verifies whether host nodes are serving genuine unquantized model weights.</a:t>
             </a:r>
           </a:p>
           <a:p>
@@ -8427,21 +8481,21 @@
               </a:defRPr>
             </a:pPr>
             <a:r>
-              <a:t>• Real-Time Clearing Engine: Automated 50 bps fee calculation and microsecond balance verification preventing overdrafts.</a:t>
-            </a:r>
-          </a:p>
-        </p:txBody>
-      </p:sp>
-      <p:sp>
-        <p:nvSpPr>
-          <p:cNvPr id="9" name="Rounded Rectangle 8"/>
+              <a:t>• Cryptographic Slashing Proofs: Automated on-chain slashing triggers when model output deviates from ground truth.</a:t>
+            </a:r>
+          </a:p>
+        </p:txBody>
+      </p:sp>
+      <p:sp>
+        <p:nvSpPr>
+          <p:cNvPr id="10" name="Rounded Rectangle 9"/>
           <p:cNvSpPr/>
           <p:nvPr/>
         </p:nvSpPr>
         <p:spPr>
           <a:xfrm>
-            <a:off x="6080760" y="3657600"/>
-            <a:ext cx="5257800" cy="2148840"/>
+            <a:off x="6080760" y="4069080"/>
+            <a:ext cx="5257800" cy="2057400"/>
           </a:xfrm>
           <a:prstGeom prst="roundRect">
             <a:avLst/>
@@ -8470,18 +8524,18 @@
           </a:fontRef>
         </p:style>
         <p:txBody>
-          <a:bodyPr rtlCol="0" anchor="ctr" wrap="square" lIns="164592" tIns="164592" rIns="164592" bIns="164592"/>
+          <a:bodyPr rtlCol="0" anchor="ctr" wrap="square" lIns="146304" tIns="146304" rIns="146304" bIns="146304"/>
           <a:lstStyle/>
           <a:p>
             <a:pPr algn="ctr">
-              <a:defRPr b="1" sz="1100">
+              <a:defRPr b="1" sz="1050">
                 <a:solidFill>
                   <a:srgbClr val="C084FC"/>
                 </a:solidFill>
               </a:defRPr>
             </a:pPr>
             <a:r>
-              <a:t>4. HARDWARE NODE CLUSTER INTEGRATION &amp; BENCHMARKS</a:t>
+              <a:t>4. FINANCIAL DATABASE &amp; PRODUCTION CLUSTER</a:t>
             </a:r>
           </a:p>
           <a:p>
@@ -8493,7 +8547,7 @@
               </a:defRPr>
             </a:pPr>
             <a:r>
-              <a:t>• Prague Bare-Metal GPU Host: Configured `bulbasaur-prague-01` running Vulkan-accelerated local Qwen models with zero-overhead tunnels.</a:t>
+              <a:t>• Charizard PostgreSQL Ledger: Strict schema-isolated ledger (`verxl.*`) recording micro-settlements and balances.</a:t>
             </a:r>
           </a:p>
           <a:p>
@@ -8505,7 +8559,7 @@
               </a:defRPr>
             </a:pPr>
             <a:r>
-              <a:t>• Diglett Server Orchestration: Configured Honcho persistent AI memory and OMP autonomous agents syncing keys from Charizard in real-time.</a:t>
+              <a:t>• RFC 6238 TOTP 2FA Infrastructure: PBKDF2 password hashing (100k rounds), pure WebCrypto TOTP validation, and 8 emergency codes.</a:t>
             </a:r>
           </a:p>
           <a:p>
@@ -8517,7 +8571,7 @@
               </a:defRPr>
             </a:pPr>
             <a:r>
-              <a:t>• Live Production Testing: Conducted continuous stress testing across local, VPS, and cloud nodes to guarantee 99.99% uptime.</a:t>
+              <a:t>• Prague Bare-Metal GPU Host: `bulbasaur-prague-01` running Vulkan-accelerated local Qwen models with zero-overhead tunnels.</a:t>
             </a:r>
           </a:p>
         </p:txBody>
@@ -8762,7 +8816,7 @@
         <p:spPr>
           <a:xfrm>
             <a:off x="548640" y="365760"/>
-            <a:ext cx="11064240" cy="731520"/>
+            <a:ext cx="11064240" cy="777240"/>
           </a:xfrm>
           <a:prstGeom prst="rect">
             <a:avLst/>
@@ -8776,7 +8830,7 @@
           <a:lstStyle/>
           <a:p>
             <a:pPr>
-              <a:defRPr sz="2400" b="1">
+              <a:defRPr sz="2300" b="1">
                 <a:solidFill>
                   <a:srgbClr val="FFFFFF"/>
                 </a:solidFill>
@@ -8789,7 +8843,7 @@
           </a:p>
           <a:p>
             <a:pPr>
-              <a:defRPr sz="1300">
+              <a:defRPr sz="1200">
                 <a:solidFill>
                   <a:srgbClr val="38BDF8"/>
                 </a:solidFill>
@@ -8811,7 +8865,7 @@
         <p:spPr>
           <a:xfrm>
             <a:off x="548640" y="1371600"/>
-            <a:ext cx="10789920" cy="914400"/>
+            <a:ext cx="10789920" cy="868680"/>
           </a:xfrm>
           <a:prstGeom prst="rect">
             <a:avLst/>
@@ -8840,30 +8894,30 @@
           </a:fontRef>
         </p:style>
         <p:txBody>
-          <a:bodyPr rtlCol="0" anchor="ctr" wrap="square" lIns="137160" tIns="137160" rIns="137160" bIns="137160"/>
+          <a:bodyPr rtlCol="0" anchor="ctr" wrap="square" lIns="109728" tIns="109728" rIns="109728" bIns="109728"/>
           <a:lstStyle/>
           <a:p>
             <a:pPr algn="ctr">
-              <a:defRPr b="1" sz="1200">
+              <a:defRPr b="1" sz="1150">
                 <a:solidFill>
                   <a:srgbClr val="38BDF8"/>
                 </a:solidFill>
               </a:defRPr>
             </a:pPr>
             <a:r>
-              <a:t>CORE OBJECTIVE: BECOME THE DECENTRALIZED CLEARINGHOUSE FOR GLOBAL AI</a:t>
-            </a:r>
-          </a:p>
-          <a:p>
-            <a:pPr>
-              <a:defRPr sz="950">
+              <a:t>CORE OBJECTIVE: THE NASDAQ / VISA OF ARTIFICIAL INTELLIGENCE COMPUTE</a:t>
+            </a:r>
+          </a:p>
+          <a:p>
+            <a:pPr>
+              <a:defRPr sz="900">
                 <a:solidFill>
                   <a:srgbClr val="FFFFFF"/>
                 </a:solidFill>
               </a:defRPr>
             </a:pPr>
             <a:r>
-              <a:t>Visa does not own retail stores; NASDAQ does not own stocks; Airbnb does not build hotels. Verxl never buys GPUs or signs datacenter leases. We are a pure financial clearing layer connecting high-volume AI consumers with distributed GPU compute clusters.</a:t>
+              <a:t>Visa does not own retail stores; NASDAQ does not own stocks; Airbnb does not build hotels. Verxl never buys GPUs, leases server rooms, or pays power bills. We are a pure financial clearing layer taking 50 basis points on every inference dollar.</a:t>
             </a:r>
           </a:p>
         </p:txBody>
@@ -8876,8 +8930,8 @@
         </p:nvSpPr>
         <p:spPr>
           <a:xfrm>
-            <a:off x="548640" y="2468880"/>
-            <a:ext cx="3474720" cy="3291840"/>
+            <a:off x="548640" y="2423160"/>
+            <a:ext cx="3474720" cy="3337560"/>
           </a:xfrm>
           <a:prstGeom prst="roundRect">
             <a:avLst/>
@@ -8906,11 +8960,11 @@
           </a:fontRef>
         </p:style>
         <p:txBody>
-          <a:bodyPr rtlCol="0" anchor="ctr" wrap="square" lIns="182880" tIns="182880" rIns="182880" bIns="182880"/>
+          <a:bodyPr rtlCol="0" anchor="ctr" wrap="square" lIns="164592" tIns="164592" rIns="164592" bIns="164592"/>
           <a:lstStyle/>
           <a:p>
             <a:pPr algn="ctr">
-              <a:defRPr b="1" sz="1200">
+              <a:defRPr b="1" sz="1150">
                 <a:solidFill>
                   <a:srgbClr val="94A3B8"/>
                 </a:solidFill>
@@ -8922,7 +8976,7 @@
           </a:p>
           <a:p>
             <a:pPr>
-              <a:defRPr sz="1000">
+              <a:defRPr sz="950">
                 <a:solidFill>
                   <a:srgbClr val="FFFFFF"/>
                 </a:solidFill>
@@ -8934,7 +8988,7 @@
           </a:p>
           <a:p>
             <a:pPr>
-              <a:defRPr sz="1000">
+              <a:defRPr sz="950">
                 <a:solidFill>
                   <a:srgbClr val="FFFFFF"/>
                 </a:solidFill>
@@ -8946,7 +9000,7 @@
           </a:p>
           <a:p>
             <a:pPr>
-              <a:defRPr sz="1000">
+              <a:defRPr sz="950">
                 <a:solidFill>
                   <a:srgbClr val="FFFFFF"/>
                 </a:solidFill>
@@ -8958,7 +9012,7 @@
           </a:p>
           <a:p>
             <a:pPr>
-              <a:defRPr sz="1000">
+              <a:defRPr sz="950">
                 <a:solidFill>
                   <a:srgbClr val="FFFFFF"/>
                 </a:solidFill>
@@ -8991,8 +9045,8 @@
         </p:nvSpPr>
         <p:spPr>
           <a:xfrm>
-            <a:off x="4206240" y="2468880"/>
-            <a:ext cx="3474720" cy="3291840"/>
+            <a:off x="4206240" y="2423160"/>
+            <a:ext cx="3474720" cy="3337560"/>
           </a:xfrm>
           <a:prstGeom prst="roundRect">
             <a:avLst/>
@@ -9021,11 +9075,11 @@
           </a:fontRef>
         </p:style>
         <p:txBody>
-          <a:bodyPr rtlCol="0" anchor="ctr" wrap="square" lIns="182880" tIns="182880" rIns="182880" bIns="182880"/>
+          <a:bodyPr rtlCol="0" anchor="ctr" wrap="square" lIns="164592" tIns="164592" rIns="164592" bIns="164592"/>
           <a:lstStyle/>
           <a:p>
             <a:pPr algn="ctr">
-              <a:defRPr b="1" sz="1200">
+              <a:defRPr b="1" sz="1150">
                 <a:solidFill>
                   <a:srgbClr val="38BDF8"/>
                 </a:solidFill>
@@ -9037,7 +9091,7 @@
           </a:p>
           <a:p>
             <a:pPr>
-              <a:defRPr sz="1000">
+              <a:defRPr sz="950">
                 <a:solidFill>
                   <a:srgbClr val="FFFFFF"/>
                 </a:solidFill>
@@ -9049,7 +9103,7 @@
           </a:p>
           <a:p>
             <a:pPr>
-              <a:defRPr sz="1000">
+              <a:defRPr sz="950">
                 <a:solidFill>
                   <a:srgbClr val="FFFFFF"/>
                 </a:solidFill>
@@ -9061,7 +9115,7 @@
           </a:p>
           <a:p>
             <a:pPr>
-              <a:defRPr sz="1000">
+              <a:defRPr sz="950">
                 <a:solidFill>
                   <a:srgbClr val="FFFFFF"/>
                 </a:solidFill>
@@ -9073,7 +9127,7 @@
           </a:p>
           <a:p>
             <a:pPr>
-              <a:defRPr sz="1000">
+              <a:defRPr sz="950">
                 <a:solidFill>
                   <a:srgbClr val="FFFFFF"/>
                 </a:solidFill>
@@ -9093,7 +9147,7 @@
               </a:defRPr>
             </a:pPr>
             <a:r>
-              <a:t>Focus: Expansion into algorithmic quant funds, automated customer service agents, and DeFi bots.</a:t>
+              <a:t>Focus: Expansion into quant funds, autonomous agents, and commercial DeFi pipelines.</a:t>
             </a:r>
           </a:p>
         </p:txBody>
@@ -9106,8 +9160,8 @@
         </p:nvSpPr>
         <p:spPr>
           <a:xfrm>
-            <a:off x="7863840" y="2468880"/>
-            <a:ext cx="3474720" cy="3291840"/>
+            <a:off x="7863840" y="2423160"/>
+            <a:ext cx="3474720" cy="3337560"/>
           </a:xfrm>
           <a:prstGeom prst="roundRect">
             <a:avLst/>
@@ -9136,11 +9190,11 @@
           </a:fontRef>
         </p:style>
         <p:txBody>
-          <a:bodyPr rtlCol="0" anchor="ctr" wrap="square" lIns="182880" tIns="182880" rIns="182880" bIns="182880"/>
+          <a:bodyPr rtlCol="0" anchor="ctr" wrap="square" lIns="164592" tIns="164592" rIns="164592" bIns="164592"/>
           <a:lstStyle/>
           <a:p>
             <a:pPr algn="ctr">
-              <a:defRPr b="1" sz="1200">
+              <a:defRPr b="1" sz="1150">
                 <a:solidFill>
                   <a:srgbClr val="34D399"/>
                 </a:solidFill>
@@ -9152,7 +9206,7 @@
           </a:p>
           <a:p>
             <a:pPr>
-              <a:defRPr sz="1000">
+              <a:defRPr sz="950">
                 <a:solidFill>
                   <a:srgbClr val="FFFFFF"/>
                 </a:solidFill>
@@ -9164,7 +9218,7 @@
           </a:p>
           <a:p>
             <a:pPr>
-              <a:defRPr sz="1000">
+              <a:defRPr sz="950">
                 <a:solidFill>
                   <a:srgbClr val="FFFFFF"/>
                 </a:solidFill>
@@ -9176,7 +9230,7 @@
           </a:p>
           <a:p>
             <a:pPr>
-              <a:defRPr sz="1000">
+              <a:defRPr sz="950">
                 <a:solidFill>
                   <a:srgbClr val="FFFFFF"/>
                 </a:solidFill>
@@ -9188,14 +9242,14 @@
           </a:p>
           <a:p>
             <a:pPr>
-              <a:defRPr sz="1000">
+              <a:defRPr sz="950">
                 <a:solidFill>
                   <a:srgbClr val="FFFFFF"/>
                 </a:solidFill>
               </a:defRPr>
             </a:pPr>
             <a:r>
-              <a:t>Connected Clusters: 1,000+ Fleets</a:t>
+              <a:t>Connected Clusters: 1,000+ Distributed Fleets</a:t>
             </a:r>
           </a:p>
           <a:p>

</xml_diff>

<commit_message>
feat(vision): integrate Daniel Kolárovský & Miroslava Valová portraits, elevate team visibility and purge seminar room slop
</commit_message>
<xml_diff>
--- a/Verxl_Protocol_Pitch_Presentation.pptx
+++ b/Verxl_Protocol_Pitch_Presentation.pptx
@@ -1360,7 +1360,7 @@
           </a:p>
           <a:p>
             <a:r>
-              <a:t>Verxl is built on four proprietary pillars: First, on-chain Aragon OSx contracts manage non-custodial escrows and collateral. Second, our stateless edge router dispatches requests in 3.8 milliseconds with zero proxy latency. Third, our seed=42 canary oracle continuously audits provider output, slashing degraded nodes by 10%. And fourth, our Charizard PostgreSQL ledger manages real-time balance clearing with 2FA security. We note our core team: Šimon Havlík leading architecture and full-stack engineering, collaborating with academic project partners at VŠE.</a:t>
+              <a:t>Verxl is built on four proprietary pillars: First, on-chain Aragon OSx contracts manage non-custodial escrows and collateral. Second, our stateless edge router dispatches requests in 3.8 milliseconds with zero proxy latency. Third, our seed=42 canary oracle continuously audits provider output, slashing degraded nodes by 10%. And fourth, our Charizard PostgreSQL ledger manages real-time balance clearing with 2FA security. Our core team comprises Šimon Havlík leading architecture and full-stack engineering, Daniel Kolárovský directing empirical SLA testing and process verification, and Miroslava Valová leading regulatory compliance, market research, and institutional governance.</a:t>
             </a:r>
           </a:p>
         </p:txBody>
@@ -8157,7 +8157,7 @@
               </a:defRPr>
             </a:pPr>
             <a:r>
-              <a:t>Engineered by Šimon Havlík (Lead Architect) · Academic Collaboration with VŠE Partners</a:t>
+              <a:t>Engineered by Šimon Havlík, Daniel Kolárovský &amp; Miroslava Valová · Founding Assembly at VŠE Praha</a:t>
             </a:r>
           </a:p>
         </p:txBody>
@@ -8211,7 +8211,7 @@
               </a:defRPr>
             </a:pPr>
             <a:r>
-              <a:t>👥 CORE TEAM: Šimon Havlík (Lead Protocol Architect &amp; Full-Stack Developer)  |  Academic Project Partners: VŠE Praha</a:t>
+              <a:t>👥 CORE TEAM: Šimon Havlík (Lead Architect &amp; Dev)  |  Daniel Kolárovský (QA &amp; Process Audit)  |  Miroslava Valová (Regulatory &amp; Strategy)</a:t>
             </a:r>
           </a:p>
         </p:txBody>

</xml_diff>